<commit_message>
Add scenarios slide to partner deck
New slide 10 ('Three ways the model runs') lays out the three
monetisation scenarios (Tight & Local, B2B Heavy, Full Throttle Lean)
as three cards: revenue headline, margin, split, footfall, spend,
charge and a verdict line each, with Scenario B marked recommended via
an acid top border. Full-width assumptions footnote below. Close slide
renumbered to 11; footer total bumped to 11. Also fixed the cover
heading the rename missed (Camden Crawl -> Hidden Camden).

Co-Authored-By: Claude Opus 4.8 <noreply@anthropic.com>
Claude-Session: https://claude.ai/code/session_0175UYdBX1WcexsbLAzm2exE
</commit_message>
<xml_diff>
--- a/pitch/camden-crawl-deck.pptx
+++ b/pitch/camden-crawl-deck.pptx
@@ -15,6 +15,7 @@
     <p:sldId id="263" r:id="rId14"/>
     <p:sldId id="264" r:id="rId15"/>
     <p:sldId id="265" r:id="rId16"/>
+    <p:sldId id="266" r:id="rId17"/>
   </p:sldIdLst>
   <p:sldSz cx="12188952" cy="6858000" type="screen4x3"/>
   <p:notesSz cx="6858000" cy="9144000"/>
@@ -3412,8 +3413,8 @@
                 </a:solidFill>
                 <a:latin typeface="Anton"/>
               </a:rPr>
-              <a:t>CAMDEN
-CRAWL</a:t>
+              <a:t>HIDDEN
+CAMDEN</a:t>
             </a:r>
           </a:p>
         </p:txBody>
@@ -3485,7 +3486,7 @@
                 </a:solidFill>
                 <a:latin typeface="Space Grotesk"/>
               </a:rPr>
-              <a:t>CAMDEN CRAWL</a:t>
+              <a:t>HIDDEN CAMDEN</a:t>
             </a:r>
           </a:p>
         </p:txBody>
@@ -3520,7 +3521,7 @@
                 </a:solidFill>
                 <a:latin typeface="Space Grotesk"/>
               </a:rPr>
-              <a:t>01 / 10</a:t>
+              <a:t>01 / 11</a:t>
             </a:r>
           </a:p>
         </p:txBody>
@@ -3588,6 +3589,1809 @@
       </p:sp>
       <p:sp>
         <p:nvSpPr>
+          <p:cNvPr id="3" name="TextBox 2"/>
+          <p:cNvSpPr txBox="1"/>
+          <p:nvPr/>
+        </p:nvSpPr>
+        <p:spPr>
+          <a:xfrm>
+            <a:off x="777240" y="548640"/>
+            <a:ext cx="9144000" cy="320040"/>
+          </a:xfrm>
+          <a:prstGeom prst="rect">
+            <a:avLst/>
+          </a:prstGeom>
+          <a:noFill/>
+        </p:spPr>
+        <p:txBody>
+          <a:bodyPr wrap="square">
+            <a:spAutoFit/>
+          </a:bodyPr>
+          <a:lstStyle/>
+          <a:p>
+            <a:pPr algn="l"/>
+            <a:r>
+              <a:rPr sz="900" b="1" i="0">
+                <a:solidFill>
+                  <a:srgbClr val="CCFF00"/>
+                </a:solidFill>
+                <a:latin typeface="Space Grotesk"/>
+              </a:rPr>
+              <a:t>WHAT IT EARNS</a:t>
+            </a:r>
+          </a:p>
+        </p:txBody>
+      </p:sp>
+      <p:sp>
+        <p:nvSpPr>
+          <p:cNvPr id="4" name="TextBox 3"/>
+          <p:cNvSpPr txBox="1"/>
+          <p:nvPr/>
+        </p:nvSpPr>
+        <p:spPr>
+          <a:xfrm>
+            <a:off x="777240" y="896112"/>
+            <a:ext cx="10515600" cy="2286000"/>
+          </a:xfrm>
+          <a:prstGeom prst="rect">
+            <a:avLst/>
+          </a:prstGeom>
+          <a:noFill/>
+        </p:spPr>
+        <p:txBody>
+          <a:bodyPr wrap="square">
+            <a:spAutoFit/>
+          </a:bodyPr>
+          <a:lstStyle/>
+          <a:p>
+            <a:pPr algn="l"/>
+            <a:r>
+              <a:rPr sz="3600" b="0" i="0">
+                <a:solidFill>
+                  <a:srgbClr val="F5F5F7"/>
+                </a:solidFill>
+                <a:latin typeface="Anton"/>
+              </a:rPr>
+              <a:t>THREE WAYS THE MODEL RUNS.</a:t>
+            </a:r>
+          </a:p>
+        </p:txBody>
+      </p:sp>
+      <p:sp>
+        <p:nvSpPr>
+          <p:cNvPr id="5" name="Rectangle 4"/>
+          <p:cNvSpPr/>
+          <p:nvPr/>
+        </p:nvSpPr>
+        <p:spPr>
+          <a:xfrm>
+            <a:off x="457200" y="1920240"/>
+            <a:ext cx="3694176" cy="3794760"/>
+          </a:xfrm>
+          <a:prstGeom prst="rect">
+            <a:avLst/>
+          </a:prstGeom>
+          <a:solidFill>
+            <a:srgbClr val="111113"/>
+          </a:solidFill>
+          <a:ln w="9525">
+            <a:solidFill>
+              <a:srgbClr val="28282C"/>
+            </a:solidFill>
+          </a:ln>
+        </p:spPr>
+        <p:style>
+          <a:lnRef idx="1">
+            <a:schemeClr val="accent1"/>
+          </a:lnRef>
+          <a:fillRef idx="3">
+            <a:schemeClr val="accent1"/>
+          </a:fillRef>
+          <a:effectRef idx="2">
+            <a:schemeClr val="accent1"/>
+          </a:effectRef>
+          <a:fontRef idx="minor">
+            <a:schemeClr val="lt1"/>
+          </a:fontRef>
+        </p:style>
+        <p:txBody>
+          <a:bodyPr rtlCol="0" anchor="ctr"/>
+          <a:lstStyle/>
+          <a:p>
+            <a:pPr algn="ctr"/>
+          </a:p>
+        </p:txBody>
+      </p:sp>
+      <p:sp>
+        <p:nvSpPr>
+          <p:cNvPr id="6" name="TextBox 5"/>
+          <p:cNvSpPr txBox="1"/>
+          <p:nvPr/>
+        </p:nvSpPr>
+        <p:spPr>
+          <a:xfrm>
+            <a:off x="640080" y="2066544"/>
+            <a:ext cx="3328416" cy="274320"/>
+          </a:xfrm>
+          <a:prstGeom prst="rect">
+            <a:avLst/>
+          </a:prstGeom>
+          <a:noFill/>
+        </p:spPr>
+        <p:txBody>
+          <a:bodyPr wrap="square">
+            <a:spAutoFit/>
+          </a:bodyPr>
+          <a:lstStyle/>
+          <a:p>
+            <a:pPr algn="l"/>
+            <a:r>
+              <a:rPr sz="900" b="1" i="0">
+                <a:solidFill>
+                  <a:srgbClr val="CCFF00"/>
+                </a:solidFill>
+                <a:latin typeface="Space Grotesk"/>
+              </a:rPr>
+              <a:t>SCENARIO A</a:t>
+            </a:r>
+          </a:p>
+        </p:txBody>
+      </p:sp>
+      <p:sp>
+        <p:nvSpPr>
+          <p:cNvPr id="7" name="TextBox 6"/>
+          <p:cNvSpPr txBox="1"/>
+          <p:nvPr/>
+        </p:nvSpPr>
+        <p:spPr>
+          <a:xfrm>
+            <a:off x="640080" y="2286000"/>
+            <a:ext cx="3328416" cy="457200"/>
+          </a:xfrm>
+          <a:prstGeom prst="rect">
+            <a:avLst/>
+          </a:prstGeom>
+          <a:noFill/>
+        </p:spPr>
+        <p:txBody>
+          <a:bodyPr wrap="square">
+            <a:spAutoFit/>
+          </a:bodyPr>
+          <a:lstStyle/>
+          <a:p>
+            <a:pPr algn="l"/>
+            <a:r>
+              <a:rPr sz="1900" b="0" i="0">
+                <a:solidFill>
+                  <a:srgbClr val="F5F5F7"/>
+                </a:solidFill>
+                <a:latin typeface="Anton"/>
+              </a:rPr>
+              <a:t>TIGHT &amp; LOCAL</a:t>
+            </a:r>
+          </a:p>
+        </p:txBody>
+      </p:sp>
+      <p:sp>
+        <p:nvSpPr>
+          <p:cNvPr id="8" name="TextBox 7"/>
+          <p:cNvSpPr txBox="1"/>
+          <p:nvPr/>
+        </p:nvSpPr>
+        <p:spPr>
+          <a:xfrm>
+            <a:off x="640080" y="2633472"/>
+            <a:ext cx="3328416" cy="548640"/>
+          </a:xfrm>
+          <a:prstGeom prst="rect">
+            <a:avLst/>
+          </a:prstGeom>
+          <a:noFill/>
+        </p:spPr>
+        <p:txBody>
+          <a:bodyPr wrap="square">
+            <a:spAutoFit/>
+          </a:bodyPr>
+          <a:lstStyle/>
+          <a:p>
+            <a:pPr algn="l"/>
+            <a:r>
+              <a:rPr sz="3000" b="0" i="0">
+                <a:solidFill>
+                  <a:srgbClr val="CCFF00"/>
+                </a:solidFill>
+                <a:latin typeface="Anton"/>
+              </a:rPr>
+              <a:t>£148K</a:t>
+            </a:r>
+          </a:p>
+        </p:txBody>
+      </p:sp>
+      <p:sp>
+        <p:nvSpPr>
+          <p:cNvPr id="9" name="TextBox 8"/>
+          <p:cNvSpPr txBox="1"/>
+          <p:nvPr/>
+        </p:nvSpPr>
+        <p:spPr>
+          <a:xfrm>
+            <a:off x="640080" y="3182112"/>
+            <a:ext cx="3328416" cy="274320"/>
+          </a:xfrm>
+          <a:prstGeom prst="rect">
+            <a:avLst/>
+          </a:prstGeom>
+          <a:noFill/>
+        </p:spPr>
+        <p:txBody>
+          <a:bodyPr wrap="square">
+            <a:spAutoFit/>
+          </a:bodyPr>
+          <a:lstStyle/>
+          <a:p>
+            <a:pPr algn="l"/>
+            <a:r>
+              <a:rPr sz="850" b="1" i="0">
+                <a:solidFill>
+                  <a:srgbClr val="98989D"/>
+                </a:solidFill>
+                <a:latin typeface="Space Grotesk"/>
+              </a:rPr>
+              <a:t>PER YEAR · 37% MARGIN</a:t>
+            </a:r>
+          </a:p>
+        </p:txBody>
+      </p:sp>
+      <p:sp>
+        <p:nvSpPr>
+          <p:cNvPr id="10" name="TextBox 9"/>
+          <p:cNvSpPr txBox="1"/>
+          <p:nvPr/>
+        </p:nvSpPr>
+        <p:spPr>
+          <a:xfrm>
+            <a:off x="640080" y="3401568"/>
+            <a:ext cx="3328416" cy="274320"/>
+          </a:xfrm>
+          <a:prstGeom prst="rect">
+            <a:avLst/>
+          </a:prstGeom>
+          <a:noFill/>
+        </p:spPr>
+        <p:txBody>
+          <a:bodyPr wrap="square">
+            <a:spAutoFit/>
+          </a:bodyPr>
+          <a:lstStyle/>
+          <a:p>
+            <a:pPr algn="l"/>
+            <a:r>
+              <a:rPr sz="1100" b="0" i="0">
+                <a:solidFill>
+                  <a:srgbClr val="F5F5F7"/>
+                </a:solidFill>
+                <a:latin typeface="Jost"/>
+              </a:rPr>
+              <a:t>You £89k · Partner £59k</a:t>
+            </a:r>
+          </a:p>
+        </p:txBody>
+      </p:sp>
+      <p:sp>
+        <p:nvSpPr>
+          <p:cNvPr id="11" name="Rectangle 10"/>
+          <p:cNvSpPr/>
+          <p:nvPr/>
+        </p:nvSpPr>
+        <p:spPr>
+          <a:xfrm>
+            <a:off x="640080" y="3730752"/>
+            <a:ext cx="3328416" cy="19050"/>
+          </a:xfrm>
+          <a:prstGeom prst="rect">
+            <a:avLst/>
+          </a:prstGeom>
+          <a:solidFill>
+            <a:srgbClr val="28282C"/>
+          </a:solidFill>
+          <a:ln>
+            <a:noFill/>
+          </a:ln>
+        </p:spPr>
+        <p:style>
+          <a:lnRef idx="1">
+            <a:schemeClr val="accent1"/>
+          </a:lnRef>
+          <a:fillRef idx="3">
+            <a:schemeClr val="accent1"/>
+          </a:fillRef>
+          <a:effectRef idx="2">
+            <a:schemeClr val="accent1"/>
+          </a:effectRef>
+          <a:fontRef idx="minor">
+            <a:schemeClr val="lt1"/>
+          </a:fontRef>
+        </p:style>
+        <p:txBody>
+          <a:bodyPr rtlCol="0" anchor="ctr"/>
+          <a:lstStyle/>
+          <a:p>
+            <a:pPr algn="ctr"/>
+          </a:p>
+        </p:txBody>
+      </p:sp>
+      <p:sp>
+        <p:nvSpPr>
+          <p:cNvPr id="12" name="TextBox 11"/>
+          <p:cNvSpPr txBox="1"/>
+          <p:nvPr/>
+        </p:nvSpPr>
+        <p:spPr>
+          <a:xfrm>
+            <a:off x="640080" y="3822192"/>
+            <a:ext cx="3328416" cy="201168"/>
+          </a:xfrm>
+          <a:prstGeom prst="rect">
+            <a:avLst/>
+          </a:prstGeom>
+          <a:noFill/>
+        </p:spPr>
+        <p:txBody>
+          <a:bodyPr wrap="square">
+            <a:spAutoFit/>
+          </a:bodyPr>
+          <a:lstStyle/>
+          <a:p>
+            <a:pPr algn="l"/>
+            <a:r>
+              <a:rPr sz="800" b="1" i="0">
+                <a:solidFill>
+                  <a:srgbClr val="CCFF00"/>
+                </a:solidFill>
+                <a:latin typeface="Space Grotesk"/>
+              </a:rPr>
+              <a:t>FOOTFALL</a:t>
+            </a:r>
+          </a:p>
+        </p:txBody>
+      </p:sp>
+      <p:sp>
+        <p:nvSpPr>
+          <p:cNvPr id="13" name="TextBox 12"/>
+          <p:cNvSpPr txBox="1"/>
+          <p:nvPr/>
+        </p:nvSpPr>
+        <p:spPr>
+          <a:xfrm>
+            <a:off x="640080" y="3995928"/>
+            <a:ext cx="3328416" cy="457200"/>
+          </a:xfrm>
+          <a:prstGeom prst="rect">
+            <a:avLst/>
+          </a:prstGeom>
+          <a:noFill/>
+        </p:spPr>
+        <p:txBody>
+          <a:bodyPr wrap="square">
+            <a:spAutoFit/>
+          </a:bodyPr>
+          <a:lstStyle/>
+          <a:p>
+            <a:pPr algn="l"/>
+            <a:r>
+              <a:rPr sz="900" b="0" i="0">
+                <a:solidFill>
+                  <a:srgbClr val="F5F5F7"/>
+                </a:solidFill>
+                <a:latin typeface="Jost"/>
+              </a:rPr>
+              <a:t>~12.5k tour-starts/mo (8k organic + 4.5k bought) → 1.2k paid tours</a:t>
+            </a:r>
+          </a:p>
+        </p:txBody>
+      </p:sp>
+      <p:sp>
+        <p:nvSpPr>
+          <p:cNvPr id="14" name="TextBox 13"/>
+          <p:cNvSpPr txBox="1"/>
+          <p:nvPr/>
+        </p:nvSpPr>
+        <p:spPr>
+          <a:xfrm>
+            <a:off x="640080" y="4325112"/>
+            <a:ext cx="3328416" cy="201168"/>
+          </a:xfrm>
+          <a:prstGeom prst="rect">
+            <a:avLst/>
+          </a:prstGeom>
+          <a:noFill/>
+        </p:spPr>
+        <p:txBody>
+          <a:bodyPr wrap="square">
+            <a:spAutoFit/>
+          </a:bodyPr>
+          <a:lstStyle/>
+          <a:p>
+            <a:pPr algn="l"/>
+            <a:r>
+              <a:rPr sz="800" b="1" i="0">
+                <a:solidFill>
+                  <a:srgbClr val="CCFF00"/>
+                </a:solidFill>
+                <a:latin typeface="Space Grotesk"/>
+              </a:rPr>
+              <a:t>SPEND</a:t>
+            </a:r>
+          </a:p>
+        </p:txBody>
+      </p:sp>
+      <p:sp>
+        <p:nvSpPr>
+          <p:cNvPr id="15" name="TextBox 14"/>
+          <p:cNvSpPr txBox="1"/>
+          <p:nvPr/>
+        </p:nvSpPr>
+        <p:spPr>
+          <a:xfrm>
+            <a:off x="640080" y="4498848"/>
+            <a:ext cx="3328416" cy="457200"/>
+          </a:xfrm>
+          <a:prstGeom prst="rect">
+            <a:avLst/>
+          </a:prstGeom>
+          <a:noFill/>
+        </p:spPr>
+        <p:txBody>
+          <a:bodyPr wrap="square">
+            <a:spAutoFit/>
+          </a:bodyPr>
+          <a:lstStyle/>
+          <a:p>
+            <a:pPr algn="l"/>
+            <a:r>
+              <a:rPr sz="900" b="0" i="0">
+                <a:solidFill>
+                  <a:srgbClr val="F5F5F7"/>
+                </a:solidFill>
+                <a:latin typeface="Jost"/>
+              </a:rPr>
+              <a:t>Street team £5k · Online £2k · Billboards £0 · Fixed £5k → £12k out</a:t>
+            </a:r>
+          </a:p>
+        </p:txBody>
+      </p:sp>
+      <p:sp>
+        <p:nvSpPr>
+          <p:cNvPr id="16" name="TextBox 15"/>
+          <p:cNvSpPr txBox="1"/>
+          <p:nvPr/>
+        </p:nvSpPr>
+        <p:spPr>
+          <a:xfrm>
+            <a:off x="640080" y="4828032"/>
+            <a:ext cx="3328416" cy="201168"/>
+          </a:xfrm>
+          <a:prstGeom prst="rect">
+            <a:avLst/>
+          </a:prstGeom>
+          <a:noFill/>
+        </p:spPr>
+        <p:txBody>
+          <a:bodyPr wrap="square">
+            <a:spAutoFit/>
+          </a:bodyPr>
+          <a:lstStyle/>
+          <a:p>
+            <a:pPr algn="l"/>
+            <a:r>
+              <a:rPr sz="800" b="1" i="0">
+                <a:solidFill>
+                  <a:srgbClr val="CCFF00"/>
+                </a:solidFill>
+                <a:latin typeface="Space Grotesk"/>
+              </a:rPr>
+              <a:t>CHARGE</a:t>
+            </a:r>
+          </a:p>
+        </p:txBody>
+      </p:sp>
+      <p:sp>
+        <p:nvSpPr>
+          <p:cNvPr id="17" name="TextBox 16"/>
+          <p:cNvSpPr txBox="1"/>
+          <p:nvPr/>
+        </p:nvSpPr>
+        <p:spPr>
+          <a:xfrm>
+            <a:off x="640080" y="5001768"/>
+            <a:ext cx="3328416" cy="457200"/>
+          </a:xfrm>
+          <a:prstGeom prst="rect">
+            <a:avLst/>
+          </a:prstGeom>
+          <a:noFill/>
+        </p:spPr>
+        <p:txBody>
+          <a:bodyPr wrap="square">
+            <a:spAutoFit/>
+          </a:bodyPr>
+          <a:lstStyle/>
+          <a:p>
+            <a:pPr algn="l"/>
+            <a:r>
+              <a:rPr sz="900" b="0" i="0">
+                <a:solidFill>
+                  <a:srgbClr val="F5F5F7"/>
+                </a:solidFill>
+                <a:latin typeface="Jost"/>
+              </a:rPr>
+              <a:t>2 sponsors @ £4k · 8 venues @ £100 · Tour £4.99 · Booze £1.50/serve · Merch</a:t>
+            </a:r>
+          </a:p>
+        </p:txBody>
+      </p:sp>
+      <p:sp>
+        <p:nvSpPr>
+          <p:cNvPr id="18" name="TextBox 17"/>
+          <p:cNvSpPr txBox="1"/>
+          <p:nvPr/>
+        </p:nvSpPr>
+        <p:spPr>
+          <a:xfrm>
+            <a:off x="640080" y="5376672"/>
+            <a:ext cx="3328416" cy="292608"/>
+          </a:xfrm>
+          <a:prstGeom prst="rect">
+            <a:avLst/>
+          </a:prstGeom>
+          <a:noFill/>
+        </p:spPr>
+        <p:txBody>
+          <a:bodyPr wrap="square">
+            <a:spAutoFit/>
+          </a:bodyPr>
+          <a:lstStyle/>
+          <a:p>
+            <a:pPr algn="l"/>
+            <a:r>
+              <a:rPr sz="1050" b="0" i="1">
+                <a:solidFill>
+                  <a:srgbClr val="CCFF00"/>
+                </a:solidFill>
+                <a:latin typeface="Jost"/>
+              </a:rPr>
+              <a:t>Bootstrap it. Profit from day one.</a:t>
+            </a:r>
+          </a:p>
+        </p:txBody>
+      </p:sp>
+      <p:sp>
+        <p:nvSpPr>
+          <p:cNvPr id="19" name="Rectangle 18"/>
+          <p:cNvSpPr/>
+          <p:nvPr/>
+        </p:nvSpPr>
+        <p:spPr>
+          <a:xfrm>
+            <a:off x="4274820" y="1920240"/>
+            <a:ext cx="3694176" cy="3794760"/>
+          </a:xfrm>
+          <a:prstGeom prst="rect">
+            <a:avLst/>
+          </a:prstGeom>
+          <a:solidFill>
+            <a:srgbClr val="111113"/>
+          </a:solidFill>
+          <a:ln w="19050">
+            <a:solidFill>
+              <a:srgbClr val="CCFF00"/>
+            </a:solidFill>
+          </a:ln>
+        </p:spPr>
+        <p:style>
+          <a:lnRef idx="1">
+            <a:schemeClr val="accent1"/>
+          </a:lnRef>
+          <a:fillRef idx="3">
+            <a:schemeClr val="accent1"/>
+          </a:fillRef>
+          <a:effectRef idx="2">
+            <a:schemeClr val="accent1"/>
+          </a:effectRef>
+          <a:fontRef idx="minor">
+            <a:schemeClr val="lt1"/>
+          </a:fontRef>
+        </p:style>
+        <p:txBody>
+          <a:bodyPr rtlCol="0" anchor="ctr"/>
+          <a:lstStyle/>
+          <a:p>
+            <a:pPr algn="ctr"/>
+          </a:p>
+        </p:txBody>
+      </p:sp>
+      <p:sp>
+        <p:nvSpPr>
+          <p:cNvPr id="20" name="Rectangle 19"/>
+          <p:cNvSpPr/>
+          <p:nvPr/>
+        </p:nvSpPr>
+        <p:spPr>
+          <a:xfrm>
+            <a:off x="4274820" y="1920240"/>
+            <a:ext cx="3694176" cy="38100"/>
+          </a:xfrm>
+          <a:prstGeom prst="rect">
+            <a:avLst/>
+          </a:prstGeom>
+          <a:solidFill>
+            <a:srgbClr val="CCFF00"/>
+          </a:solidFill>
+          <a:ln>
+            <a:noFill/>
+          </a:ln>
+        </p:spPr>
+        <p:style>
+          <a:lnRef idx="1">
+            <a:schemeClr val="accent1"/>
+          </a:lnRef>
+          <a:fillRef idx="3">
+            <a:schemeClr val="accent1"/>
+          </a:fillRef>
+          <a:effectRef idx="2">
+            <a:schemeClr val="accent1"/>
+          </a:effectRef>
+          <a:fontRef idx="minor">
+            <a:schemeClr val="lt1"/>
+          </a:fontRef>
+        </p:style>
+        <p:txBody>
+          <a:bodyPr rtlCol="0" anchor="ctr"/>
+          <a:lstStyle/>
+          <a:p>
+            <a:pPr algn="ctr"/>
+          </a:p>
+        </p:txBody>
+      </p:sp>
+      <p:sp>
+        <p:nvSpPr>
+          <p:cNvPr id="21" name="TextBox 20"/>
+          <p:cNvSpPr txBox="1"/>
+          <p:nvPr/>
+        </p:nvSpPr>
+        <p:spPr>
+          <a:xfrm>
+            <a:off x="4457700" y="2066544"/>
+            <a:ext cx="3328416" cy="274320"/>
+          </a:xfrm>
+          <a:prstGeom prst="rect">
+            <a:avLst/>
+          </a:prstGeom>
+          <a:noFill/>
+        </p:spPr>
+        <p:txBody>
+          <a:bodyPr wrap="square">
+            <a:spAutoFit/>
+          </a:bodyPr>
+          <a:lstStyle/>
+          <a:p>
+            <a:pPr algn="l"/>
+            <a:r>
+              <a:rPr sz="900" b="1" i="0">
+                <a:solidFill>
+                  <a:srgbClr val="CCFF00"/>
+                </a:solidFill>
+                <a:latin typeface="Space Grotesk"/>
+              </a:rPr>
+              <a:t>SCENARIO B</a:t>
+            </a:r>
+          </a:p>
+        </p:txBody>
+      </p:sp>
+      <p:sp>
+        <p:nvSpPr>
+          <p:cNvPr id="22" name="TextBox 21"/>
+          <p:cNvSpPr txBox="1"/>
+          <p:nvPr/>
+        </p:nvSpPr>
+        <p:spPr>
+          <a:xfrm>
+            <a:off x="4457700" y="2286000"/>
+            <a:ext cx="3328416" cy="457200"/>
+          </a:xfrm>
+          <a:prstGeom prst="rect">
+            <a:avLst/>
+          </a:prstGeom>
+          <a:noFill/>
+        </p:spPr>
+        <p:txBody>
+          <a:bodyPr wrap="square">
+            <a:spAutoFit/>
+          </a:bodyPr>
+          <a:lstStyle/>
+          <a:p>
+            <a:pPr algn="l"/>
+            <a:r>
+              <a:rPr sz="1900" b="0" i="0">
+                <a:solidFill>
+                  <a:srgbClr val="F5F5F7"/>
+                </a:solidFill>
+                <a:latin typeface="Anton"/>
+              </a:rPr>
+              <a:t>B2B HEAVY</a:t>
+            </a:r>
+          </a:p>
+        </p:txBody>
+      </p:sp>
+      <p:sp>
+        <p:nvSpPr>
+          <p:cNvPr id="23" name="TextBox 22"/>
+          <p:cNvSpPr txBox="1"/>
+          <p:nvPr/>
+        </p:nvSpPr>
+        <p:spPr>
+          <a:xfrm>
+            <a:off x="4457700" y="2633472"/>
+            <a:ext cx="3328416" cy="548640"/>
+          </a:xfrm>
+          <a:prstGeom prst="rect">
+            <a:avLst/>
+          </a:prstGeom>
+          <a:noFill/>
+        </p:spPr>
+        <p:txBody>
+          <a:bodyPr wrap="square">
+            <a:spAutoFit/>
+          </a:bodyPr>
+          <a:lstStyle/>
+          <a:p>
+            <a:pPr algn="l"/>
+            <a:r>
+              <a:rPr sz="3000" b="0" i="0">
+                <a:solidFill>
+                  <a:srgbClr val="CCFF00"/>
+                </a:solidFill>
+                <a:latin typeface="Anton"/>
+              </a:rPr>
+              <a:t>£398K</a:t>
+            </a:r>
+          </a:p>
+        </p:txBody>
+      </p:sp>
+      <p:sp>
+        <p:nvSpPr>
+          <p:cNvPr id="24" name="TextBox 23"/>
+          <p:cNvSpPr txBox="1"/>
+          <p:nvPr/>
+        </p:nvSpPr>
+        <p:spPr>
+          <a:xfrm>
+            <a:off x="4457700" y="3182112"/>
+            <a:ext cx="3328416" cy="274320"/>
+          </a:xfrm>
+          <a:prstGeom prst="rect">
+            <a:avLst/>
+          </a:prstGeom>
+          <a:noFill/>
+        </p:spPr>
+        <p:txBody>
+          <a:bodyPr wrap="square">
+            <a:spAutoFit/>
+          </a:bodyPr>
+          <a:lstStyle/>
+          <a:p>
+            <a:pPr algn="l"/>
+            <a:r>
+              <a:rPr sz="850" b="1" i="0">
+                <a:solidFill>
+                  <a:srgbClr val="98989D"/>
+                </a:solidFill>
+                <a:latin typeface="Space Grotesk"/>
+              </a:rPr>
+              <a:t>PER YEAR · 44% MARGIN</a:t>
+            </a:r>
+          </a:p>
+        </p:txBody>
+      </p:sp>
+      <p:sp>
+        <p:nvSpPr>
+          <p:cNvPr id="25" name="TextBox 24"/>
+          <p:cNvSpPr txBox="1"/>
+          <p:nvPr/>
+        </p:nvSpPr>
+        <p:spPr>
+          <a:xfrm>
+            <a:off x="4457700" y="3401568"/>
+            <a:ext cx="3328416" cy="274320"/>
+          </a:xfrm>
+          <a:prstGeom prst="rect">
+            <a:avLst/>
+          </a:prstGeom>
+          <a:noFill/>
+        </p:spPr>
+        <p:txBody>
+          <a:bodyPr wrap="square">
+            <a:spAutoFit/>
+          </a:bodyPr>
+          <a:lstStyle/>
+          <a:p>
+            <a:pPr algn="l"/>
+            <a:r>
+              <a:rPr sz="1100" b="0" i="0">
+                <a:solidFill>
+                  <a:srgbClr val="F5F5F7"/>
+                </a:solidFill>
+                <a:latin typeface="Jost"/>
+              </a:rPr>
+              <a:t>You £239k · Partner £159k</a:t>
+            </a:r>
+          </a:p>
+        </p:txBody>
+      </p:sp>
+      <p:sp>
+        <p:nvSpPr>
+          <p:cNvPr id="26" name="Rectangle 25"/>
+          <p:cNvSpPr/>
+          <p:nvPr/>
+        </p:nvSpPr>
+        <p:spPr>
+          <a:xfrm>
+            <a:off x="4457700" y="3730752"/>
+            <a:ext cx="3328416" cy="19050"/>
+          </a:xfrm>
+          <a:prstGeom prst="rect">
+            <a:avLst/>
+          </a:prstGeom>
+          <a:solidFill>
+            <a:srgbClr val="28282C"/>
+          </a:solidFill>
+          <a:ln>
+            <a:noFill/>
+          </a:ln>
+        </p:spPr>
+        <p:style>
+          <a:lnRef idx="1">
+            <a:schemeClr val="accent1"/>
+          </a:lnRef>
+          <a:fillRef idx="3">
+            <a:schemeClr val="accent1"/>
+          </a:fillRef>
+          <a:effectRef idx="2">
+            <a:schemeClr val="accent1"/>
+          </a:effectRef>
+          <a:fontRef idx="minor">
+            <a:schemeClr val="lt1"/>
+          </a:fontRef>
+        </p:style>
+        <p:txBody>
+          <a:bodyPr rtlCol="0" anchor="ctr"/>
+          <a:lstStyle/>
+          <a:p>
+            <a:pPr algn="ctr"/>
+          </a:p>
+        </p:txBody>
+      </p:sp>
+      <p:sp>
+        <p:nvSpPr>
+          <p:cNvPr id="27" name="TextBox 26"/>
+          <p:cNvSpPr txBox="1"/>
+          <p:nvPr/>
+        </p:nvSpPr>
+        <p:spPr>
+          <a:xfrm>
+            <a:off x="4457700" y="3822192"/>
+            <a:ext cx="3328416" cy="201168"/>
+          </a:xfrm>
+          <a:prstGeom prst="rect">
+            <a:avLst/>
+          </a:prstGeom>
+          <a:noFill/>
+        </p:spPr>
+        <p:txBody>
+          <a:bodyPr wrap="square">
+            <a:spAutoFit/>
+          </a:bodyPr>
+          <a:lstStyle/>
+          <a:p>
+            <a:pPr algn="l"/>
+            <a:r>
+              <a:rPr sz="800" b="1" i="0">
+                <a:solidFill>
+                  <a:srgbClr val="CCFF00"/>
+                </a:solidFill>
+                <a:latin typeface="Space Grotesk"/>
+              </a:rPr>
+              <a:t>FOOTFALL</a:t>
+            </a:r>
+          </a:p>
+        </p:txBody>
+      </p:sp>
+      <p:sp>
+        <p:nvSpPr>
+          <p:cNvPr id="28" name="TextBox 27"/>
+          <p:cNvSpPr txBox="1"/>
+          <p:nvPr/>
+        </p:nvSpPr>
+        <p:spPr>
+          <a:xfrm>
+            <a:off x="4457700" y="3995928"/>
+            <a:ext cx="3328416" cy="457200"/>
+          </a:xfrm>
+          <a:prstGeom prst="rect">
+            <a:avLst/>
+          </a:prstGeom>
+          <a:noFill/>
+        </p:spPr>
+        <p:txBody>
+          <a:bodyPr wrap="square">
+            <a:spAutoFit/>
+          </a:bodyPr>
+          <a:lstStyle/>
+          <a:p>
+            <a:pPr algn="l"/>
+            <a:r>
+              <a:rPr sz="900" b="0" i="0">
+                <a:solidFill>
+                  <a:srgbClr val="F5F5F7"/>
+                </a:solidFill>
+                <a:latin typeface="Jost"/>
+              </a:rPr>
+              <a:t>~22k tour-starts/mo (15k organic + 7k bought) → 1.8k paid tours</a:t>
+            </a:r>
+          </a:p>
+        </p:txBody>
+      </p:sp>
+      <p:sp>
+        <p:nvSpPr>
+          <p:cNvPr id="29" name="TextBox 28"/>
+          <p:cNvSpPr txBox="1"/>
+          <p:nvPr/>
+        </p:nvSpPr>
+        <p:spPr>
+          <a:xfrm>
+            <a:off x="4457700" y="4325112"/>
+            <a:ext cx="3328416" cy="201168"/>
+          </a:xfrm>
+          <a:prstGeom prst="rect">
+            <a:avLst/>
+          </a:prstGeom>
+          <a:noFill/>
+        </p:spPr>
+        <p:txBody>
+          <a:bodyPr wrap="square">
+            <a:spAutoFit/>
+          </a:bodyPr>
+          <a:lstStyle/>
+          <a:p>
+            <a:pPr algn="l"/>
+            <a:r>
+              <a:rPr sz="800" b="1" i="0">
+                <a:solidFill>
+                  <a:srgbClr val="CCFF00"/>
+                </a:solidFill>
+                <a:latin typeface="Space Grotesk"/>
+              </a:rPr>
+              <a:t>SPEND</a:t>
+            </a:r>
+          </a:p>
+        </p:txBody>
+      </p:sp>
+      <p:sp>
+        <p:nvSpPr>
+          <p:cNvPr id="30" name="TextBox 29"/>
+          <p:cNvSpPr txBox="1"/>
+          <p:nvPr/>
+        </p:nvSpPr>
+        <p:spPr>
+          <a:xfrm>
+            <a:off x="4457700" y="4498848"/>
+            <a:ext cx="3328416" cy="457200"/>
+          </a:xfrm>
+          <a:prstGeom prst="rect">
+            <a:avLst/>
+          </a:prstGeom>
+          <a:noFill/>
+        </p:spPr>
+        <p:txBody>
+          <a:bodyPr wrap="square">
+            <a:spAutoFit/>
+          </a:bodyPr>
+          <a:lstStyle/>
+          <a:p>
+            <a:pPr algn="l"/>
+            <a:r>
+              <a:rPr sz="900" b="0" i="0">
+                <a:solidFill>
+                  <a:srgbClr val="F5F5F7"/>
+                </a:solidFill>
+                <a:latin typeface="Jost"/>
+              </a:rPr>
+              <a:t>Street team £6k · Online £6k · Billboards £4k · Fixed £9k → £25k out</a:t>
+            </a:r>
+          </a:p>
+        </p:txBody>
+      </p:sp>
+      <p:sp>
+        <p:nvSpPr>
+          <p:cNvPr id="31" name="TextBox 30"/>
+          <p:cNvSpPr txBox="1"/>
+          <p:nvPr/>
+        </p:nvSpPr>
+        <p:spPr>
+          <a:xfrm>
+            <a:off x="4457700" y="4828032"/>
+            <a:ext cx="3328416" cy="201168"/>
+          </a:xfrm>
+          <a:prstGeom prst="rect">
+            <a:avLst/>
+          </a:prstGeom>
+          <a:noFill/>
+        </p:spPr>
+        <p:txBody>
+          <a:bodyPr wrap="square">
+            <a:spAutoFit/>
+          </a:bodyPr>
+          <a:lstStyle/>
+          <a:p>
+            <a:pPr algn="l"/>
+            <a:r>
+              <a:rPr sz="800" b="1" i="0">
+                <a:solidFill>
+                  <a:srgbClr val="CCFF00"/>
+                </a:solidFill>
+                <a:latin typeface="Space Grotesk"/>
+              </a:rPr>
+              <a:t>CHARGE</a:t>
+            </a:r>
+          </a:p>
+        </p:txBody>
+      </p:sp>
+      <p:sp>
+        <p:nvSpPr>
+          <p:cNvPr id="32" name="TextBox 31"/>
+          <p:cNvSpPr txBox="1"/>
+          <p:nvPr/>
+        </p:nvSpPr>
+        <p:spPr>
+          <a:xfrm>
+            <a:off x="4457700" y="5001768"/>
+            <a:ext cx="3328416" cy="457200"/>
+          </a:xfrm>
+          <a:prstGeom prst="rect">
+            <a:avLst/>
+          </a:prstGeom>
+          <a:noFill/>
+        </p:spPr>
+        <p:txBody>
+          <a:bodyPr wrap="square">
+            <a:spAutoFit/>
+          </a:bodyPr>
+          <a:lstStyle/>
+          <a:p>
+            <a:pPr algn="l"/>
+            <a:r>
+              <a:rPr sz="900" b="0" i="0">
+                <a:solidFill>
+                  <a:srgbClr val="F5F5F7"/>
+                </a:solidFill>
+                <a:latin typeface="Jost"/>
+              </a:rPr>
+              <a:t>4 sponsors @ £7k · 15 venues @ £200 · Tour £3.99 · Booze £2.00/serve · Merch</a:t>
+            </a:r>
+          </a:p>
+        </p:txBody>
+      </p:sp>
+      <p:sp>
+        <p:nvSpPr>
+          <p:cNvPr id="33" name="TextBox 32"/>
+          <p:cNvSpPr txBox="1"/>
+          <p:nvPr/>
+        </p:nvSpPr>
+        <p:spPr>
+          <a:xfrm>
+            <a:off x="4457700" y="5376672"/>
+            <a:ext cx="3328416" cy="292608"/>
+          </a:xfrm>
+          <a:prstGeom prst="rect">
+            <a:avLst/>
+          </a:prstGeom>
+          <a:noFill/>
+        </p:spPr>
+        <p:txBody>
+          <a:bodyPr wrap="square">
+            <a:spAutoFit/>
+          </a:bodyPr>
+          <a:lstStyle/>
+          <a:p>
+            <a:pPr algn="l"/>
+            <a:r>
+              <a:rPr sz="1050" b="0" i="1">
+                <a:solidFill>
+                  <a:srgbClr val="CCFF00"/>
+                </a:solidFill>
+                <a:latin typeface="Jost"/>
+              </a:rPr>
+              <a:t>Sell the audience, not the tour.</a:t>
+            </a:r>
+          </a:p>
+        </p:txBody>
+      </p:sp>
+      <p:sp>
+        <p:nvSpPr>
+          <p:cNvPr id="34" name="Rectangle 33"/>
+          <p:cNvSpPr/>
+          <p:nvPr/>
+        </p:nvSpPr>
+        <p:spPr>
+          <a:xfrm>
+            <a:off x="8092440" y="1920240"/>
+            <a:ext cx="3694176" cy="3794760"/>
+          </a:xfrm>
+          <a:prstGeom prst="rect">
+            <a:avLst/>
+          </a:prstGeom>
+          <a:solidFill>
+            <a:srgbClr val="111113"/>
+          </a:solidFill>
+          <a:ln w="9525">
+            <a:solidFill>
+              <a:srgbClr val="28282C"/>
+            </a:solidFill>
+          </a:ln>
+        </p:spPr>
+        <p:style>
+          <a:lnRef idx="1">
+            <a:schemeClr val="accent1"/>
+          </a:lnRef>
+          <a:fillRef idx="3">
+            <a:schemeClr val="accent1"/>
+          </a:fillRef>
+          <a:effectRef idx="2">
+            <a:schemeClr val="accent1"/>
+          </a:effectRef>
+          <a:fontRef idx="minor">
+            <a:schemeClr val="lt1"/>
+          </a:fontRef>
+        </p:style>
+        <p:txBody>
+          <a:bodyPr rtlCol="0" anchor="ctr"/>
+          <a:lstStyle/>
+          <a:p>
+            <a:pPr algn="ctr"/>
+          </a:p>
+        </p:txBody>
+      </p:sp>
+      <p:sp>
+        <p:nvSpPr>
+          <p:cNvPr id="35" name="TextBox 34"/>
+          <p:cNvSpPr txBox="1"/>
+          <p:nvPr/>
+        </p:nvSpPr>
+        <p:spPr>
+          <a:xfrm>
+            <a:off x="8275320" y="2066544"/>
+            <a:ext cx="3328416" cy="274320"/>
+          </a:xfrm>
+          <a:prstGeom prst="rect">
+            <a:avLst/>
+          </a:prstGeom>
+          <a:noFill/>
+        </p:spPr>
+        <p:txBody>
+          <a:bodyPr wrap="square">
+            <a:spAutoFit/>
+          </a:bodyPr>
+          <a:lstStyle/>
+          <a:p>
+            <a:pPr algn="l"/>
+            <a:r>
+              <a:rPr sz="900" b="1" i="0">
+                <a:solidFill>
+                  <a:srgbClr val="CCFF00"/>
+                </a:solidFill>
+                <a:latin typeface="Space Grotesk"/>
+              </a:rPr>
+              <a:t>SCENARIO C</a:t>
+            </a:r>
+          </a:p>
+        </p:txBody>
+      </p:sp>
+      <p:sp>
+        <p:nvSpPr>
+          <p:cNvPr id="36" name="TextBox 35"/>
+          <p:cNvSpPr txBox="1"/>
+          <p:nvPr/>
+        </p:nvSpPr>
+        <p:spPr>
+          <a:xfrm>
+            <a:off x="8275320" y="2286000"/>
+            <a:ext cx="3328416" cy="457200"/>
+          </a:xfrm>
+          <a:prstGeom prst="rect">
+            <a:avLst/>
+          </a:prstGeom>
+          <a:noFill/>
+        </p:spPr>
+        <p:txBody>
+          <a:bodyPr wrap="square">
+            <a:spAutoFit/>
+          </a:bodyPr>
+          <a:lstStyle/>
+          <a:p>
+            <a:pPr algn="l"/>
+            <a:r>
+              <a:rPr sz="1900" b="0" i="0">
+                <a:solidFill>
+                  <a:srgbClr val="F5F5F7"/>
+                </a:solidFill>
+                <a:latin typeface="Anton"/>
+              </a:rPr>
+              <a:t>FULL THROTTLE LEAN</a:t>
+            </a:r>
+          </a:p>
+        </p:txBody>
+      </p:sp>
+      <p:sp>
+        <p:nvSpPr>
+          <p:cNvPr id="37" name="TextBox 36"/>
+          <p:cNvSpPr txBox="1"/>
+          <p:nvPr/>
+        </p:nvSpPr>
+        <p:spPr>
+          <a:xfrm>
+            <a:off x="8275320" y="2633472"/>
+            <a:ext cx="3328416" cy="548640"/>
+          </a:xfrm>
+          <a:prstGeom prst="rect">
+            <a:avLst/>
+          </a:prstGeom>
+          <a:noFill/>
+        </p:spPr>
+        <p:txBody>
+          <a:bodyPr wrap="square">
+            <a:spAutoFit/>
+          </a:bodyPr>
+          <a:lstStyle/>
+          <a:p>
+            <a:pPr algn="l"/>
+            <a:r>
+              <a:rPr sz="3000" b="0" i="0">
+                <a:solidFill>
+                  <a:srgbClr val="CCFF00"/>
+                </a:solidFill>
+                <a:latin typeface="Anton"/>
+              </a:rPr>
+              <a:t>£881K</a:t>
+            </a:r>
+          </a:p>
+        </p:txBody>
+      </p:sp>
+      <p:sp>
+        <p:nvSpPr>
+          <p:cNvPr id="38" name="TextBox 37"/>
+          <p:cNvSpPr txBox="1"/>
+          <p:nvPr/>
+        </p:nvSpPr>
+        <p:spPr>
+          <a:xfrm>
+            <a:off x="8275320" y="3182112"/>
+            <a:ext cx="3328416" cy="274320"/>
+          </a:xfrm>
+          <a:prstGeom prst="rect">
+            <a:avLst/>
+          </a:prstGeom>
+          <a:noFill/>
+        </p:spPr>
+        <p:txBody>
+          <a:bodyPr wrap="square">
+            <a:spAutoFit/>
+          </a:bodyPr>
+          <a:lstStyle/>
+          <a:p>
+            <a:pPr algn="l"/>
+            <a:r>
+              <a:rPr sz="850" b="1" i="0">
+                <a:solidFill>
+                  <a:srgbClr val="98989D"/>
+                </a:solidFill>
+                <a:latin typeface="Space Grotesk"/>
+              </a:rPr>
+              <a:t>PER YEAR · 47% MARGIN</a:t>
+            </a:r>
+          </a:p>
+        </p:txBody>
+      </p:sp>
+      <p:sp>
+        <p:nvSpPr>
+          <p:cNvPr id="39" name="TextBox 38"/>
+          <p:cNvSpPr txBox="1"/>
+          <p:nvPr/>
+        </p:nvSpPr>
+        <p:spPr>
+          <a:xfrm>
+            <a:off x="8275320" y="3401568"/>
+            <a:ext cx="3328416" cy="274320"/>
+          </a:xfrm>
+          <a:prstGeom prst="rect">
+            <a:avLst/>
+          </a:prstGeom>
+          <a:noFill/>
+        </p:spPr>
+        <p:txBody>
+          <a:bodyPr wrap="square">
+            <a:spAutoFit/>
+          </a:bodyPr>
+          <a:lstStyle/>
+          <a:p>
+            <a:pPr algn="l"/>
+            <a:r>
+              <a:rPr sz="1100" b="0" i="0">
+                <a:solidFill>
+                  <a:srgbClr val="F5F5F7"/>
+                </a:solidFill>
+                <a:latin typeface="Jost"/>
+              </a:rPr>
+              <a:t>You £529k · Partner £352k</a:t>
+            </a:r>
+          </a:p>
+        </p:txBody>
+      </p:sp>
+      <p:sp>
+        <p:nvSpPr>
+          <p:cNvPr id="40" name="Rectangle 39"/>
+          <p:cNvSpPr/>
+          <p:nvPr/>
+        </p:nvSpPr>
+        <p:spPr>
+          <a:xfrm>
+            <a:off x="8275320" y="3730752"/>
+            <a:ext cx="3328416" cy="19050"/>
+          </a:xfrm>
+          <a:prstGeom prst="rect">
+            <a:avLst/>
+          </a:prstGeom>
+          <a:solidFill>
+            <a:srgbClr val="28282C"/>
+          </a:solidFill>
+          <a:ln>
+            <a:noFill/>
+          </a:ln>
+        </p:spPr>
+        <p:style>
+          <a:lnRef idx="1">
+            <a:schemeClr val="accent1"/>
+          </a:lnRef>
+          <a:fillRef idx="3">
+            <a:schemeClr val="accent1"/>
+          </a:fillRef>
+          <a:effectRef idx="2">
+            <a:schemeClr val="accent1"/>
+          </a:effectRef>
+          <a:fontRef idx="minor">
+            <a:schemeClr val="lt1"/>
+          </a:fontRef>
+        </p:style>
+        <p:txBody>
+          <a:bodyPr rtlCol="0" anchor="ctr"/>
+          <a:lstStyle/>
+          <a:p>
+            <a:pPr algn="ctr"/>
+          </a:p>
+        </p:txBody>
+      </p:sp>
+      <p:sp>
+        <p:nvSpPr>
+          <p:cNvPr id="41" name="TextBox 40"/>
+          <p:cNvSpPr txBox="1"/>
+          <p:nvPr/>
+        </p:nvSpPr>
+        <p:spPr>
+          <a:xfrm>
+            <a:off x="8275320" y="3822192"/>
+            <a:ext cx="3328416" cy="201168"/>
+          </a:xfrm>
+          <a:prstGeom prst="rect">
+            <a:avLst/>
+          </a:prstGeom>
+          <a:noFill/>
+        </p:spPr>
+        <p:txBody>
+          <a:bodyPr wrap="square">
+            <a:spAutoFit/>
+          </a:bodyPr>
+          <a:lstStyle/>
+          <a:p>
+            <a:pPr algn="l"/>
+            <a:r>
+              <a:rPr sz="800" b="1" i="0">
+                <a:solidFill>
+                  <a:srgbClr val="CCFF00"/>
+                </a:solidFill>
+                <a:latin typeface="Space Grotesk"/>
+              </a:rPr>
+              <a:t>FOOTFALL</a:t>
+            </a:r>
+          </a:p>
+        </p:txBody>
+      </p:sp>
+      <p:sp>
+        <p:nvSpPr>
+          <p:cNvPr id="42" name="TextBox 41"/>
+          <p:cNvSpPr txBox="1"/>
+          <p:nvPr/>
+        </p:nvSpPr>
+        <p:spPr>
+          <a:xfrm>
+            <a:off x="8275320" y="3995928"/>
+            <a:ext cx="3328416" cy="457200"/>
+          </a:xfrm>
+          <a:prstGeom prst="rect">
+            <a:avLst/>
+          </a:prstGeom>
+          <a:noFill/>
+        </p:spPr>
+        <p:txBody>
+          <a:bodyPr wrap="square">
+            <a:spAutoFit/>
+          </a:bodyPr>
+          <a:lstStyle/>
+          <a:p>
+            <a:pPr algn="l"/>
+            <a:r>
+              <a:rPr sz="900" b="0" i="0">
+                <a:solidFill>
+                  <a:srgbClr val="F5F5F7"/>
+                </a:solidFill>
+                <a:latin typeface="Jost"/>
+              </a:rPr>
+              <a:t>~40k tour-starts/mo (30k organic + 11k bought) → 4.5k paid tours</a:t>
+            </a:r>
+          </a:p>
+        </p:txBody>
+      </p:sp>
+      <p:sp>
+        <p:nvSpPr>
+          <p:cNvPr id="43" name="TextBox 42"/>
+          <p:cNvSpPr txBox="1"/>
+          <p:nvPr/>
+        </p:nvSpPr>
+        <p:spPr>
+          <a:xfrm>
+            <a:off x="8275320" y="4325112"/>
+            <a:ext cx="3328416" cy="201168"/>
+          </a:xfrm>
+          <a:prstGeom prst="rect">
+            <a:avLst/>
+          </a:prstGeom>
+          <a:noFill/>
+        </p:spPr>
+        <p:txBody>
+          <a:bodyPr wrap="square">
+            <a:spAutoFit/>
+          </a:bodyPr>
+          <a:lstStyle/>
+          <a:p>
+            <a:pPr algn="l"/>
+            <a:r>
+              <a:rPr sz="800" b="1" i="0">
+                <a:solidFill>
+                  <a:srgbClr val="CCFF00"/>
+                </a:solidFill>
+                <a:latin typeface="Space Grotesk"/>
+              </a:rPr>
+              <a:t>SPEND</a:t>
+            </a:r>
+          </a:p>
+        </p:txBody>
+      </p:sp>
+      <p:sp>
+        <p:nvSpPr>
+          <p:cNvPr id="44" name="TextBox 43"/>
+          <p:cNvSpPr txBox="1"/>
+          <p:nvPr/>
+        </p:nvSpPr>
+        <p:spPr>
+          <a:xfrm>
+            <a:off x="8275320" y="4498848"/>
+            <a:ext cx="3328416" cy="457200"/>
+          </a:xfrm>
+          <a:prstGeom prst="rect">
+            <a:avLst/>
+          </a:prstGeom>
+          <a:noFill/>
+        </p:spPr>
+        <p:txBody>
+          <a:bodyPr wrap="square">
+            <a:spAutoFit/>
+          </a:bodyPr>
+          <a:lstStyle/>
+          <a:p>
+            <a:pPr algn="l"/>
+            <a:r>
+              <a:rPr sz="900" b="0" i="0">
+                <a:solidFill>
+                  <a:srgbClr val="F5F5F7"/>
+                </a:solidFill>
+                <a:latin typeface="Jost"/>
+              </a:rPr>
+              <a:t>Street team £8k · Online £12k · Billboards £6k · Fixed £18k → £44k out</a:t>
+            </a:r>
+          </a:p>
+        </p:txBody>
+      </p:sp>
+      <p:sp>
+        <p:nvSpPr>
+          <p:cNvPr id="45" name="TextBox 44"/>
+          <p:cNvSpPr txBox="1"/>
+          <p:nvPr/>
+        </p:nvSpPr>
+        <p:spPr>
+          <a:xfrm>
+            <a:off x="8275320" y="4828032"/>
+            <a:ext cx="3328416" cy="201168"/>
+          </a:xfrm>
+          <a:prstGeom prst="rect">
+            <a:avLst/>
+          </a:prstGeom>
+          <a:noFill/>
+        </p:spPr>
+        <p:txBody>
+          <a:bodyPr wrap="square">
+            <a:spAutoFit/>
+          </a:bodyPr>
+          <a:lstStyle/>
+          <a:p>
+            <a:pPr algn="l"/>
+            <a:r>
+              <a:rPr sz="800" b="1" i="0">
+                <a:solidFill>
+                  <a:srgbClr val="CCFF00"/>
+                </a:solidFill>
+                <a:latin typeface="Space Grotesk"/>
+              </a:rPr>
+              <a:t>CHARGE</a:t>
+            </a:r>
+          </a:p>
+        </p:txBody>
+      </p:sp>
+      <p:sp>
+        <p:nvSpPr>
+          <p:cNvPr id="46" name="TextBox 45"/>
+          <p:cNvSpPr txBox="1"/>
+          <p:nvPr/>
+        </p:nvSpPr>
+        <p:spPr>
+          <a:xfrm>
+            <a:off x="8275320" y="5001768"/>
+            <a:ext cx="3328416" cy="457200"/>
+          </a:xfrm>
+          <a:prstGeom prst="rect">
+            <a:avLst/>
+          </a:prstGeom>
+          <a:noFill/>
+        </p:spPr>
+        <p:txBody>
+          <a:bodyPr wrap="square">
+            <a:spAutoFit/>
+          </a:bodyPr>
+          <a:lstStyle/>
+          <a:p>
+            <a:pPr algn="l"/>
+            <a:r>
+              <a:rPr sz="900" b="0" i="0">
+                <a:solidFill>
+                  <a:srgbClr val="F5F5F7"/>
+                </a:solidFill>
+                <a:latin typeface="Jost"/>
+              </a:rPr>
+              <a:t>5 sponsors @ £8k · 20 venues @ £250 · Tour £4.99 + celeb upsell · Booze £2.00/serve · Merch</a:t>
+            </a:r>
+          </a:p>
+        </p:txBody>
+      </p:sp>
+      <p:sp>
+        <p:nvSpPr>
+          <p:cNvPr id="47" name="TextBox 46"/>
+          <p:cNvSpPr txBox="1"/>
+          <p:nvPr/>
+        </p:nvSpPr>
+        <p:spPr>
+          <a:xfrm>
+            <a:off x="8275320" y="5376672"/>
+            <a:ext cx="3328416" cy="292608"/>
+          </a:xfrm>
+          <a:prstGeom prst="rect">
+            <a:avLst/>
+          </a:prstGeom>
+          <a:noFill/>
+        </p:spPr>
+        <p:txBody>
+          <a:bodyPr wrap="square">
+            <a:spAutoFit/>
+          </a:bodyPr>
+          <a:lstStyle/>
+          <a:p>
+            <a:pPr algn="l"/>
+            <a:r>
+              <a:rPr sz="1050" b="0" i="1">
+                <a:solidFill>
+                  <a:srgbClr val="CCFF00"/>
+                </a:solidFill>
+                <a:latin typeface="Jost"/>
+              </a:rPr>
+              <a:t>The destination. A and B fund the climb.</a:t>
+            </a:r>
+          </a:p>
+        </p:txBody>
+      </p:sp>
+      <p:sp>
+        <p:nvSpPr>
+          <p:cNvPr id="48" name="TextBox 47"/>
+          <p:cNvSpPr txBox="1"/>
+          <p:nvPr/>
+        </p:nvSpPr>
+        <p:spPr>
+          <a:xfrm>
+            <a:off x="457200" y="5852160"/>
+            <a:ext cx="11274552" cy="548640"/>
+          </a:xfrm>
+          <a:prstGeom prst="rect">
+            <a:avLst/>
+          </a:prstGeom>
+          <a:noFill/>
+        </p:spPr>
+        <p:txBody>
+          <a:bodyPr wrap="square">
+            <a:spAutoFit/>
+          </a:bodyPr>
+          <a:lstStyle/>
+          <a:p>
+            <a:pPr algn="l"/>
+            <a:r>
+              <a:rPr sz="850" b="0" i="0">
+                <a:solidFill>
+                  <a:srgbClr val="5A5A5F"/>
+                </a:solidFill>
+                <a:latin typeface="Jost"/>
+              </a:rPr>
+              <a:t>Assumptions: Figures are monthly, directional, and pre-tax. Even the largest case is under 2% of Camden's ~2.5M monthly visitors, so volume is conservative, not heroic. The load-bearing variables are landing the sponsors (the bulk of profit), holding paid acquisition at roughly £1.40-£2.50 per tour-start, and a ~8-11% free-to-paid conversion. Sponsor counts and fees are targets, not signed deals; the rest scales off footfall the model treats as already walking past.</a:t>
+            </a:r>
+          </a:p>
+        </p:txBody>
+      </p:sp>
+      <p:sp>
+        <p:nvSpPr>
+          <p:cNvPr id="49" name="TextBox 48"/>
+          <p:cNvSpPr txBox="1"/>
+          <p:nvPr/>
+        </p:nvSpPr>
+        <p:spPr>
+          <a:xfrm>
+            <a:off x="457200" y="6446520"/>
+            <a:ext cx="2743200" cy="274320"/>
+          </a:xfrm>
+          <a:prstGeom prst="rect">
+            <a:avLst/>
+          </a:prstGeom>
+          <a:noFill/>
+        </p:spPr>
+        <p:txBody>
+          <a:bodyPr wrap="square">
+            <a:spAutoFit/>
+          </a:bodyPr>
+          <a:lstStyle/>
+          <a:p>
+            <a:pPr algn="l"/>
+            <a:r>
+              <a:rPr sz="800" b="1" i="0">
+                <a:solidFill>
+                  <a:srgbClr val="5A5A5F"/>
+                </a:solidFill>
+                <a:latin typeface="Space Grotesk"/>
+              </a:rPr>
+              <a:t>HIDDEN CAMDEN</a:t>
+            </a:r>
+          </a:p>
+        </p:txBody>
+      </p:sp>
+      <p:sp>
+        <p:nvSpPr>
+          <p:cNvPr id="50" name="TextBox 49"/>
+          <p:cNvSpPr txBox="1"/>
+          <p:nvPr/>
+        </p:nvSpPr>
+        <p:spPr>
+          <a:xfrm>
+            <a:off x="10817352" y="6446520"/>
+            <a:ext cx="1280160" cy="274320"/>
+          </a:xfrm>
+          <a:prstGeom prst="rect">
+            <a:avLst/>
+          </a:prstGeom>
+          <a:noFill/>
+        </p:spPr>
+        <p:txBody>
+          <a:bodyPr wrap="square">
+            <a:spAutoFit/>
+          </a:bodyPr>
+          <a:lstStyle/>
+          <a:p>
+            <a:pPr algn="r"/>
+            <a:r>
+              <a:rPr sz="800" b="0" i="0">
+                <a:solidFill>
+                  <a:srgbClr val="5A5A5F"/>
+                </a:solidFill>
+                <a:latin typeface="Space Grotesk"/>
+              </a:rPr>
+              <a:t>10 / 11</a:t>
+            </a:r>
+          </a:p>
+        </p:txBody>
+      </p:sp>
+    </p:spTree>
+  </p:cSld>
+  <p:clrMapOvr>
+    <a:masterClrMapping/>
+  </p:clrMapOvr>
+</p:sld>
+</file>
+
+<file path=ppt/slides/slide11.xml><?xml version="1.0" encoding="utf-8"?>
+<p:sld xmlns:a="http://schemas.openxmlformats.org/drawingml/2006/main" xmlns:p="http://schemas.openxmlformats.org/presentationml/2006/main" xmlns:r="http://schemas.openxmlformats.org/officeDocument/2006/relationships">
+  <p:cSld>
+    <p:spTree>
+      <p:nvGrpSpPr>
+        <p:cNvPr id="1" name=""/>
+        <p:cNvGrpSpPr/>
+        <p:nvPr/>
+      </p:nvGrpSpPr>
+      <p:grpSpPr/>
+      <p:sp>
+        <p:nvSpPr>
+          <p:cNvPr id="2" name="Rectangle 1"/>
+          <p:cNvSpPr/>
+          <p:nvPr/>
+        </p:nvSpPr>
+        <p:spPr>
+          <a:xfrm>
+            <a:off x="0" y="0"/>
+            <a:ext cx="12188952" cy="6858000"/>
+          </a:xfrm>
+          <a:prstGeom prst="rect">
+            <a:avLst/>
+          </a:prstGeom>
+          <a:solidFill>
+            <a:srgbClr val="000000"/>
+          </a:solidFill>
+          <a:ln>
+            <a:noFill/>
+          </a:ln>
+        </p:spPr>
+        <p:style>
+          <a:lnRef idx="1">
+            <a:schemeClr val="accent1"/>
+          </a:lnRef>
+          <a:fillRef idx="3">
+            <a:schemeClr val="accent1"/>
+          </a:fillRef>
+          <a:effectRef idx="2">
+            <a:schemeClr val="accent1"/>
+          </a:effectRef>
+          <a:fontRef idx="minor">
+            <a:schemeClr val="lt1"/>
+          </a:fontRef>
+        </p:style>
+        <p:txBody>
+          <a:bodyPr rtlCol="0" anchor="ctr"/>
+          <a:lstStyle/>
+          <a:p>
+            <a:pPr algn="ctr"/>
+          </a:p>
+        </p:txBody>
+      </p:sp>
+      <p:sp>
+        <p:nvSpPr>
           <p:cNvPr id="3" name="Rectangle 2"/>
           <p:cNvSpPr/>
           <p:nvPr/>
@@ -4044,7 +5848,7 @@
                 </a:solidFill>
                 <a:latin typeface="Space Grotesk"/>
               </a:rPr>
-              <a:t>CAMDEN CRAWL</a:t>
+              <a:t>HIDDEN CAMDEN</a:t>
             </a:r>
           </a:p>
         </p:txBody>
@@ -4079,7 +5883,7 @@
                 </a:solidFill>
                 <a:latin typeface="Space Grotesk"/>
               </a:rPr>
-              <a:t>10 / 10</a:t>
+              <a:t>11 / 11</a:t>
             </a:r>
           </a:p>
         </p:txBody>
@@ -4537,7 +6341,7 @@
                 </a:solidFill>
                 <a:latin typeface="Space Grotesk"/>
               </a:rPr>
-              <a:t>CAMDEN CRAWL</a:t>
+              <a:t>HIDDEN CAMDEN</a:t>
             </a:r>
           </a:p>
         </p:txBody>
@@ -4572,7 +6376,7 @@
                 </a:solidFill>
                 <a:latin typeface="Space Grotesk"/>
               </a:rPr>
-              <a:t>02 / 10</a:t>
+              <a:t>02 / 11</a:t>
             </a:r>
           </a:p>
         </p:txBody>
@@ -5156,7 +6960,7 @@
                 </a:solidFill>
                 <a:latin typeface="Space Grotesk"/>
               </a:rPr>
-              <a:t>CAMDEN CRAWL</a:t>
+              <a:t>HIDDEN CAMDEN</a:t>
             </a:r>
           </a:p>
         </p:txBody>
@@ -5191,7 +6995,7 @@
                 </a:solidFill>
                 <a:latin typeface="Space Grotesk"/>
               </a:rPr>
-              <a:t>03 / 10</a:t>
+              <a:t>03 / 11</a:t>
             </a:r>
           </a:p>
         </p:txBody>
@@ -6373,7 +8177,7 @@
                 </a:solidFill>
                 <a:latin typeface="Space Grotesk"/>
               </a:rPr>
-              <a:t>CAMDEN CRAWL</a:t>
+              <a:t>HIDDEN CAMDEN</a:t>
             </a:r>
           </a:p>
         </p:txBody>
@@ -6408,7 +8212,7 @@
                 </a:solidFill>
                 <a:latin typeface="Space Grotesk"/>
               </a:rPr>
-              <a:t>04 / 10</a:t>
+              <a:t>04 / 11</a:t>
             </a:r>
           </a:p>
         </p:txBody>
@@ -7209,7 +9013,7 @@
                 </a:solidFill>
                 <a:latin typeface="Space Grotesk"/>
               </a:rPr>
-              <a:t>CAMDEN CRAWL</a:t>
+              <a:t>HIDDEN CAMDEN</a:t>
             </a:r>
           </a:p>
         </p:txBody>
@@ -7244,7 +9048,7 @@
                 </a:solidFill>
                 <a:latin typeface="Space Grotesk"/>
               </a:rPr>
-              <a:t>05 / 10</a:t>
+              <a:t>05 / 11</a:t>
             </a:r>
           </a:p>
         </p:txBody>
@@ -8276,7 +10080,7 @@
                 </a:solidFill>
                 <a:latin typeface="Space Grotesk"/>
               </a:rPr>
-              <a:t>CAMDEN CRAWL</a:t>
+              <a:t>HIDDEN CAMDEN</a:t>
             </a:r>
           </a:p>
         </p:txBody>
@@ -8311,7 +10115,7 @@
                 </a:solidFill>
                 <a:latin typeface="Space Grotesk"/>
               </a:rPr>
-              <a:t>06 / 10</a:t>
+              <a:t>06 / 11</a:t>
             </a:r>
           </a:p>
         </p:txBody>
@@ -9111,7 +10915,7 @@
                 </a:solidFill>
                 <a:latin typeface="Space Grotesk"/>
               </a:rPr>
-              <a:t>CAMDEN CRAWL</a:t>
+              <a:t>HIDDEN CAMDEN</a:t>
             </a:r>
           </a:p>
         </p:txBody>
@@ -9146,7 +10950,7 @@
                 </a:solidFill>
                 <a:latin typeface="Space Grotesk"/>
               </a:rPr>
-              <a:t>07 / 10</a:t>
+              <a:t>07 / 11</a:t>
             </a:r>
           </a:p>
         </p:txBody>
@@ -9811,7 +11615,7 @@
                 </a:solidFill>
                 <a:latin typeface="Space Grotesk"/>
               </a:rPr>
-              <a:t>CAMDEN CRAWL</a:t>
+              <a:t>HIDDEN CAMDEN</a:t>
             </a:r>
           </a:p>
         </p:txBody>
@@ -9846,7 +11650,7 @@
                 </a:solidFill>
                 <a:latin typeface="Space Grotesk"/>
               </a:rPr>
-              <a:t>08 / 10</a:t>
+              <a:t>08 / 11</a:t>
             </a:r>
           </a:p>
         </p:txBody>
@@ -11039,7 +12843,7 @@
                 </a:solidFill>
                 <a:latin typeface="Space Grotesk"/>
               </a:rPr>
-              <a:t>CAMDEN CRAWL</a:t>
+              <a:t>HIDDEN CAMDEN</a:t>
             </a:r>
           </a:p>
         </p:txBody>
@@ -11074,7 +12878,7 @@
                 </a:solidFill>
                 <a:latin typeface="Space Grotesk"/>
               </a:rPr>
-              <a:t>09 / 10</a:t>
+              <a:t>09 / 11</a:t>
             </a:r>
           </a:p>
         </p:txBody>

</xml_diff>